<commit_message>
Match pricing slide to the One price, everything included layout
Adds Outsourcing Angel billing, collaboration and monthly check-ins.

Co-Authored-By: Claude Opus 5.5 <noreply@anthropic.com>
Claude-Session: https://claude.ai/code/session_01JFepqPwf7VWRrj19aSGkg1
</commit_message>
<xml_diff>
--- a/Fractional_AI_Partner_Pricing.pptx
+++ b/Fractional_AI_Partner_Pricing.pptx
@@ -108,12 +108,12 @@
   <p:extLst>
     <p:ext uri="{521415D9-36F7-43E2-AB2F-B90AF26B5E84}">
       <p14:sectionLst xmlns:p14="http://schemas.microsoft.com/office/powerpoint/2010/main">
-        <p14:section name="Pricing" id="{23d2a00a-bdeb-54ee-c81f-1a5a3e932345}">
+        <p14:section name="Pricing" id="{49164115-6995-de3d-8c69-d580a20b4bb3}">
           <p14:sldIdLst>
             <p14:sldId id="256"/>
           </p14:sldIdLst>
         </p14:section>
-        <p14:section name="Process" id="{5f7ae856-db16-bab3-b5b2-a1f0cded2b59}">
+        <p14:section name="Process" id="{0492ffc6-b5b4-7d34-2e1c-f4e126d1917a}">
           <p14:sldIdLst>
             <p14:sldId id="257"/>
           </p14:sldIdLst>
@@ -1289,7 +1289,7 @@
                 <a:ea typeface="Cambria" pitchFamily="34" charset="-122"/>
                 <a:cs typeface="Cambria" pitchFamily="34" charset="-120"/>
               </a:rPr>
-              <a:t>One price for your whole team</a:t>
+              <a:t>One price, everything included</a:t>
             </a:r>
             <a:endParaRPr lang="en-US" sz="3000" dirty="0"/>
           </a:p>
@@ -1304,11 +1304,11 @@
         <p:spPr>
           <a:xfrm>
             <a:off x="457200" y="1280160"/>
-            <a:ext cx="3291840" cy="2926080"/>
+            <a:ext cx="3017520" cy="2148840"/>
           </a:xfrm>
           <a:prstGeom prst="roundRect">
             <a:avLst>
-              <a:gd name="adj" fmla="val 2500"/>
+              <a:gd name="adj" fmla="val 2553"/>
             </a:avLst>
           </a:prstGeom>
           <a:solidFill>
@@ -1330,8 +1330,8 @@
         </p:nvSpPr>
         <p:spPr>
           <a:xfrm>
-            <a:off x="731520" y="1508760"/>
-            <a:ext cx="2743200" cy="228600"/>
+            <a:off x="731520" y="1463040"/>
+            <a:ext cx="2560320" cy="201168"/>
           </a:xfrm>
           <a:prstGeom prst="rect">
             <a:avLst/>
@@ -1347,14 +1347,14 @@
               <a:buNone/>
             </a:pPr>
             <a:r>
-              <a:rPr lang="en-US" sz="1000" b="1" spc="200" kern="0" dirty="0">
+              <a:rPr lang="en-US" sz="900" b="1" spc="200" kern="0" dirty="0">
                 <a:solidFill>
                   <a:schemeClr val="accent4"/>
                 </a:solidFill>
               </a:rPr>
-              <a:t>MONTHLY INVESTMENT</a:t>
-            </a:r>
-            <a:endParaRPr lang="en-US" sz="1000" dirty="0"/>
+              <a:t>INVESTMENT</a:t>
+            </a:r>
+            <a:endParaRPr lang="en-US" sz="900" dirty="0"/>
           </a:p>
         </p:txBody>
       </p:sp>
@@ -1366,8 +1366,8 @@
         </p:nvSpPr>
         <p:spPr>
           <a:xfrm>
-            <a:off x="731520" y="1828800"/>
-            <a:ext cx="2926080" cy="868680"/>
+            <a:off x="731520" y="1691640"/>
+            <a:ext cx="2651760" cy="731520"/>
           </a:xfrm>
           <a:prstGeom prst="rect">
             <a:avLst/>
@@ -1376,14 +1376,14 @@
           <a:ln/>
         </p:spPr>
         <p:txBody>
-          <a:bodyPr wrap="square" lIns="0" tIns="0" rIns="0" bIns="0" rtlCol="0" anchor="ctr"/>
+          <a:bodyPr wrap="square" lIns="0" tIns="0" rIns="0" bIns="0" rtlCol="0" anchor="b"/>
           <a:lstStyle/>
           <a:p>
             <a:pPr indent="0" marL="0">
               <a:buNone/>
             </a:pPr>
             <a:r>
-              <a:rPr lang="en-US" sz="5000" b="1" dirty="0">
+              <a:rPr lang="en-US" sz="4800" dirty="0">
                 <a:solidFill>
                   <a:schemeClr val="bg1"/>
                 </a:solidFill>
@@ -1391,13 +1391,13 @@
                 <a:ea typeface="Cambria" pitchFamily="34" charset="-122"/>
                 <a:cs typeface="Cambria" pitchFamily="34" charset="-120"/>
               </a:rPr>
-              <a:t>$9,000</a:t>
+              <a:t>$9K</a:t>
             </a:r>
             <a:pPr indent="0" marL="0">
               <a:buNone/>
             </a:pPr>
             <a:r>
-              <a:rPr lang="en-US" sz="1800" dirty="0">
+              <a:rPr lang="en-US" sz="1600" dirty="0">
                 <a:solidFill>
                   <a:schemeClr val="bg1"/>
                 </a:solidFill>
@@ -1407,7 +1407,7 @@
               </a:rPr>
               <a:t>  a month</a:t>
             </a:r>
-            <a:endParaRPr lang="en-US" sz="5000" dirty="0"/>
+            <a:endParaRPr lang="en-US" sz="4800" dirty="0"/>
           </a:p>
         </p:txBody>
       </p:sp>
@@ -1419,8 +1419,8 @@
         </p:nvSpPr>
         <p:spPr>
           <a:xfrm>
-            <a:off x="731520" y="2697480"/>
-            <a:ext cx="2743200" cy="274320"/>
+            <a:off x="731520" y="2514600"/>
+            <a:ext cx="2651760" cy="502920"/>
           </a:xfrm>
           <a:prstGeom prst="rect">
             <a:avLst/>
@@ -1433,17 +1433,37 @@
           <a:lstStyle/>
           <a:p>
             <a:pPr indent="0" marL="0">
-              <a:buNone/>
-            </a:pPr>
-            <a:r>
-              <a:rPr lang="en-US" sz="1500" dirty="0">
+              <a:spcAft>
+                <a:spcPts val="200"/>
+              </a:spcAft>
+              <a:buNone/>
+            </a:pPr>
+            <a:r>
+              <a:rPr lang="en-US" sz="1300" dirty="0">
                 <a:solidFill>
                   <a:schemeClr val="bg1"/>
                 </a:solidFill>
               </a:rPr>
               <a:t>plus GST</a:t>
             </a:r>
-            <a:endParaRPr lang="en-US" sz="1500" dirty="0"/>
+            <a:endParaRPr lang="en-US" sz="1300" dirty="0"/>
+          </a:p>
+          <a:p>
+            <a:pPr indent="0" marL="0">
+              <a:spcAft>
+                <a:spcPts val="200"/>
+              </a:spcAft>
+              <a:buNone/>
+            </a:pPr>
+            <a:r>
+              <a:rPr lang="en-US" sz="1300" dirty="0">
+                <a:solidFill>
+                  <a:schemeClr val="bg1"/>
+                </a:solidFill>
+              </a:rPr>
+              <a:t>Billed monthly by Outsourcing Angel</a:t>
+            </a:r>
+            <a:endParaRPr lang="en-US" sz="1300" dirty="0"/>
           </a:p>
         </p:txBody>
       </p:sp>
@@ -1455,8 +1475,8 @@
         </p:nvSpPr>
         <p:spPr>
           <a:xfrm>
-            <a:off x="731520" y="3246120"/>
-            <a:ext cx="2743200" cy="685800"/>
+            <a:off x="731520" y="3044952"/>
+            <a:ext cx="2651760" cy="228600"/>
           </a:xfrm>
           <a:prstGeom prst="rect">
             <a:avLst/>
@@ -1469,54 +1489,34 @@
           <a:lstStyle/>
           <a:p>
             <a:pPr indent="0" marL="0">
-              <a:spcAft>
-                <a:spcPts val="400"/>
-              </a:spcAft>
-              <a:buNone/>
-            </a:pPr>
-            <a:r>
-              <a:rPr lang="en-US" sz="1400" dirty="0">
+              <a:buNone/>
+            </a:pPr>
+            <a:r>
+              <a:rPr lang="en-US" sz="1000" dirty="0">
                 <a:solidFill>
                   <a:schemeClr val="accent4"/>
                 </a:solidFill>
               </a:rPr>
-              <a:t>Billed monthly</a:t>
-            </a:r>
-            <a:endParaRPr lang="en-US" sz="1400" dirty="0"/>
-          </a:p>
-          <a:p>
-            <a:pPr indent="0" marL="0">
-              <a:spcAft>
-                <a:spcPts val="400"/>
-              </a:spcAft>
-              <a:buNone/>
-            </a:pPr>
-            <a:r>
-              <a:rPr lang="en-US" sz="1400" dirty="0">
-                <a:solidFill>
-                  <a:schemeClr val="accent4"/>
-                </a:solidFill>
-              </a:rPr>
-              <a:t>Month by month, no lock-in</a:t>
-            </a:r>
-            <a:endParaRPr lang="en-US" sz="1400" dirty="0"/>
-          </a:p>
-        </p:txBody>
-      </p:sp>
-      <p:sp>
-        <p:nvSpPr>
-          <p:cNvPr id="9" name="Computation card"/>
+              <a:t>Month by month, reviewed together each month</a:t>
+            </a:r>
+            <a:endParaRPr lang="en-US" sz="1000" dirty="0"/>
+          </a:p>
+        </p:txBody>
+      </p:sp>
+      <p:sp>
+        <p:nvSpPr>
+          <p:cNvPr id="9" name="Included panel"/>
           <p:cNvSpPr/>
           <p:nvPr/>
         </p:nvSpPr>
         <p:spPr>
           <a:xfrm>
-            <a:off x="3977640" y="1280160"/>
-            <a:ext cx="4709160" cy="2926080"/>
+            <a:off x="3657600" y="1280160"/>
+            <a:ext cx="5029200" cy="2148840"/>
           </a:xfrm>
           <a:prstGeom prst="roundRect">
             <a:avLst>
-              <a:gd name="adj" fmla="val 2500"/>
+              <a:gd name="adj" fmla="val 2553"/>
             </a:avLst>
           </a:prstGeom>
           <a:solidFill>
@@ -1538,8 +1538,8 @@
         </p:nvSpPr>
         <p:spPr>
           <a:xfrm>
-            <a:off x="4251960" y="1463040"/>
-            <a:ext cx="4206240" cy="228600"/>
+            <a:off x="3931920" y="1463040"/>
+            <a:ext cx="4572000" cy="201168"/>
           </a:xfrm>
           <a:prstGeom prst="rect">
             <a:avLst/>
@@ -1560,7 +1560,7 @@
                   <a:schemeClr val="accent1"/>
                 </a:solidFill>
               </a:rPr>
-              <a:t>THE FULL COMPUTATION</a:t>
+              <a:t>WHAT IS INCLUDED</a:t>
             </a:r>
             <a:endParaRPr lang="en-US" sz="1000" dirty="0"/>
           </a:p>
@@ -1574,8 +1574,8 @@
         </p:nvSpPr>
         <p:spPr>
           <a:xfrm>
-            <a:off x="4251960" y="1783080"/>
-            <a:ext cx="2743200" cy="274320"/>
+            <a:off x="3931920" y="1755648"/>
+            <a:ext cx="4572000" cy="1508760"/>
           </a:xfrm>
           <a:prstGeom prst="rect">
             <a:avLst/>
@@ -1584,150 +1584,122 @@
           <a:ln/>
         </p:spPr>
         <p:txBody>
-          <a:bodyPr wrap="square" lIns="0" tIns="0" rIns="0" bIns="0" rtlCol="0" anchor="ctr"/>
-          <a:lstStyle/>
-          <a:p>
-            <a:pPr indent="0" marL="0">
-              <a:buNone/>
-            </a:pPr>
-            <a:r>
-              <a:rPr lang="en-US" sz="1400" dirty="0">
+          <a:bodyPr wrap="square" lIns="0" tIns="0" rIns="0" bIns="0" rtlCol="0" anchor="t"/>
+          <a:lstStyle/>
+          <a:p>
+            <a:pPr marL="177800" indent="-177800">
+              <a:spcAft>
+                <a:spcPts val="500"/>
+              </a:spcAft>
+              <a:buSzPct val="100000"/>
+              <a:buChar char="•"/>
+            </a:pPr>
+            <a:r>
+              <a:rPr lang="en-US" sz="1300" dirty="0">
                 <a:solidFill>
                   <a:schemeClr val="tx1"/>
                 </a:solidFill>
               </a:rPr>
-              <a:t>Monthly fee</a:t>
-            </a:r>
-            <a:endParaRPr lang="en-US" sz="1400" dirty="0"/>
-          </a:p>
-        </p:txBody>
-      </p:sp>
-      <p:sp>
-        <p:nvSpPr>
-          <p:cNvPr id="12" name="Text 10"/>
-          <p:cNvSpPr txBox="1"/>
-          <p:nvPr/>
-        </p:nvSpPr>
-        <p:spPr>
-          <a:xfrm>
-            <a:off x="6903720" y="1783080"/>
-            <a:ext cx="1508760" cy="274320"/>
-          </a:xfrm>
-          <a:prstGeom prst="rect">
-            <a:avLst/>
-          </a:prstGeom>
-          <a:noFill/>
-          <a:ln/>
-        </p:spPr>
-        <p:txBody>
-          <a:bodyPr wrap="square" lIns="0" tIns="0" rIns="0" bIns="0" rtlCol="0" anchor="ctr"/>
-          <a:lstStyle/>
-          <a:p>
-            <a:pPr algn="r" indent="0" marL="0">
-              <a:buNone/>
-            </a:pPr>
-            <a:r>
-              <a:rPr lang="en-US" sz="1400" dirty="0">
+              <a:t>A one-on-one session for every person on the team</a:t>
+            </a:r>
+            <a:endParaRPr lang="en-US" sz="1300" dirty="0"/>
+          </a:p>
+          <a:p>
+            <a:pPr marL="177800" indent="-177800">
+              <a:spcAft>
+                <a:spcPts val="500"/>
+              </a:spcAft>
+              <a:buSzPct val="100000"/>
+              <a:buChar char="•"/>
+            </a:pPr>
+            <a:r>
+              <a:rPr lang="en-US" sz="1300" dirty="0">
                 <a:solidFill>
                   <a:schemeClr val="tx1"/>
                 </a:solidFill>
               </a:rPr>
-              <a:t>$9,000</a:t>
-            </a:r>
-            <a:endParaRPr lang="en-US" sz="1400" dirty="0"/>
-          </a:p>
-        </p:txBody>
-      </p:sp>
-      <p:sp>
-        <p:nvSpPr>
-          <p:cNvPr id="13" name="Text 11"/>
-          <p:cNvSpPr txBox="1"/>
-          <p:nvPr/>
-        </p:nvSpPr>
-        <p:spPr>
-          <a:xfrm>
-            <a:off x="4251960" y="2075688"/>
-            <a:ext cx="2743200" cy="274320"/>
-          </a:xfrm>
-          <a:prstGeom prst="rect">
-            <a:avLst/>
-          </a:prstGeom>
-          <a:noFill/>
-          <a:ln/>
-        </p:spPr>
-        <p:txBody>
-          <a:bodyPr wrap="square" lIns="0" tIns="0" rIns="0" bIns="0" rtlCol="0" anchor="ctr"/>
-          <a:lstStyle/>
-          <a:p>
-            <a:pPr indent="0" marL="0">
-              <a:buNone/>
-            </a:pPr>
-            <a:r>
-              <a:rPr lang="en-US" sz="1400" dirty="0">
+              <a:t>Group training and 4 or 5 team meetings</a:t>
+            </a:r>
+            <a:endParaRPr lang="en-US" sz="1300" dirty="0"/>
+          </a:p>
+          <a:p>
+            <a:pPr marL="177800" indent="-177800">
+              <a:spcAft>
+                <a:spcPts val="500"/>
+              </a:spcAft>
+              <a:buSzPct val="100000"/>
+              <a:buChar char="•"/>
+            </a:pPr>
+            <a:r>
+              <a:rPr lang="en-US" sz="1300" dirty="0">
                 <a:solidFill>
                   <a:schemeClr val="tx1"/>
                 </a:solidFill>
               </a:rPr>
-              <a:t>GST (10%)</a:t>
-            </a:r>
-            <a:endParaRPr lang="en-US" sz="1400" dirty="0"/>
-          </a:p>
-        </p:txBody>
-      </p:sp>
-      <p:sp>
-        <p:nvSpPr>
-          <p:cNvPr id="14" name="Text 12"/>
-          <p:cNvSpPr txBox="1"/>
-          <p:nvPr/>
-        </p:nvSpPr>
-        <p:spPr>
-          <a:xfrm>
-            <a:off x="6903720" y="2075688"/>
-            <a:ext cx="1508760" cy="274320"/>
-          </a:xfrm>
-          <a:prstGeom prst="rect">
-            <a:avLst/>
-          </a:prstGeom>
-          <a:noFill/>
-          <a:ln/>
-        </p:spPr>
-        <p:txBody>
-          <a:bodyPr wrap="square" lIns="0" tIns="0" rIns="0" bIns="0" rtlCol="0" anchor="ctr"/>
-          <a:lstStyle/>
-          <a:p>
-            <a:pPr algn="r" indent="0" marL="0">
-              <a:buNone/>
-            </a:pPr>
-            <a:r>
-              <a:rPr lang="en-US" sz="1400" dirty="0">
+              <a:t>The automations, including the progress payment agent</a:t>
+            </a:r>
+            <a:endParaRPr lang="en-US" sz="1300" dirty="0"/>
+          </a:p>
+          <a:p>
+            <a:pPr marL="177800" indent="-177800">
+              <a:spcAft>
+                <a:spcPts val="500"/>
+              </a:spcAft>
+              <a:buSzPct val="100000"/>
+              <a:buChar char="•"/>
+            </a:pPr>
+            <a:r>
+              <a:rPr lang="en-US" sz="1300" dirty="0">
                 <a:solidFill>
                   <a:schemeClr val="tx1"/>
                 </a:solidFill>
               </a:rPr>
-              <a:t>$900</a:t>
-            </a:r>
-            <a:endParaRPr lang="en-US" sz="1400" dirty="0"/>
-          </a:p>
-        </p:txBody>
-      </p:sp>
-      <p:sp>
-        <p:nvSpPr>
-          <p:cNvPr id="15" name="Shape 13"/>
+              <a:t>Support and ongoing improvement</a:t>
+            </a:r>
+            <a:endParaRPr lang="en-US" sz="1300" dirty="0"/>
+          </a:p>
+          <a:p>
+            <a:pPr marL="177800" indent="-177800">
+              <a:spcAft>
+                <a:spcPts val="500"/>
+              </a:spcAft>
+              <a:buSzPct val="100000"/>
+              <a:buChar char="•"/>
+            </a:pPr>
+            <a:r>
+              <a:rPr lang="en-US" sz="1300" dirty="0">
+                <a:solidFill>
+                  <a:schemeClr val="tx1"/>
+                </a:solidFill>
+              </a:rPr>
+              <a:t>A monthly check-in with Outsourcing Angel</a:t>
+            </a:r>
+            <a:endParaRPr lang="en-US" sz="1300" dirty="0"/>
+          </a:p>
+        </p:txBody>
+      </p:sp>
+      <p:sp>
+        <p:nvSpPr>
+          <p:cNvPr id="12" name="Partner note"/>
           <p:cNvSpPr/>
           <p:nvPr/>
         </p:nvSpPr>
         <p:spPr>
           <a:xfrm>
-            <a:off x="4251960" y="2395728"/>
-            <a:ext cx="4160520" cy="0"/>
-          </a:xfrm>
-          <a:prstGeom prst="line">
-            <a:avLst/>
-          </a:prstGeom>
-          <a:noFill/>
-          <a:ln w="9525">
+            <a:off x="457200" y="3611880"/>
+            <a:ext cx="8229600" cy="1005840"/>
+          </a:xfrm>
+          <a:prstGeom prst="roundRect">
+            <a:avLst>
+              <a:gd name="adj" fmla="val 5455"/>
+            </a:avLst>
+          </a:prstGeom>
+          <a:solidFill>
+            <a:schemeClr val="accent2"/>
+          </a:solidFill>
+          <a:ln w="12700">
             <a:solidFill>
-              <a:schemeClr val="accent4"/>
+              <a:schemeClr val="accent6"/>
             </a:solidFill>
             <a:prstDash val="solid"/>
           </a:ln>
@@ -1735,14 +1707,14 @@
       </p:sp>
       <p:sp>
         <p:nvSpPr>
-          <p:cNvPr id="16" name="Text 14"/>
+          <p:cNvPr id="13" name="Text 11"/>
           <p:cNvSpPr txBox="1"/>
           <p:nvPr/>
         </p:nvSpPr>
         <p:spPr>
           <a:xfrm>
-            <a:off x="4251960" y="2468880"/>
-            <a:ext cx="2743200" cy="274320"/>
+            <a:off x="685800" y="3703320"/>
+            <a:ext cx="7772400" cy="822960"/>
           </a:xfrm>
           <a:prstGeom prst="rect">
             <a:avLst/>
@@ -1755,375 +1727,51 @@
           <a:lstStyle/>
           <a:p>
             <a:pPr indent="0" marL="0">
-              <a:buNone/>
-            </a:pPr>
-            <a:r>
-              <a:rPr lang="en-US" sz="1400" b="1" dirty="0">
+              <a:spcAft>
+                <a:spcPts val="400"/>
+              </a:spcAft>
+              <a:buNone/>
+            </a:pPr>
+            <a:r>
+              <a:rPr lang="en-US" sz="1200" b="1" dirty="0">
+                <a:solidFill>
+                  <a:schemeClr val="tx2"/>
+                </a:solidFill>
+              </a:rPr>
+              <a:t>Outsourcing Angel is with you the whole way. </a:t>
+            </a:r>
+            <a:pPr indent="0" marL="0">
+              <a:spcAft>
+                <a:spcPts val="400"/>
+              </a:spcAft>
+              <a:buNone/>
+            </a:pPr>
+            <a:r>
+              <a:rPr lang="en-US" sz="1200" dirty="0">
                 <a:solidFill>
                   <a:schemeClr val="tx1"/>
                 </a:solidFill>
               </a:rPr>
-              <a:t>Total per month</a:t>
-            </a:r>
-            <a:endParaRPr lang="en-US" sz="1400" dirty="0"/>
-          </a:p>
-        </p:txBody>
-      </p:sp>
-      <p:sp>
-        <p:nvSpPr>
-          <p:cNvPr id="17" name="Text 15"/>
-          <p:cNvSpPr txBox="1"/>
-          <p:nvPr/>
-        </p:nvSpPr>
-        <p:spPr>
-          <a:xfrm>
-            <a:off x="6903720" y="2468880"/>
-            <a:ext cx="1508760" cy="274320"/>
-          </a:xfrm>
-          <a:prstGeom prst="rect">
-            <a:avLst/>
-          </a:prstGeom>
-          <a:noFill/>
-          <a:ln/>
-        </p:spPr>
-        <p:txBody>
-          <a:bodyPr wrap="square" lIns="0" tIns="0" rIns="0" bIns="0" rtlCol="0" anchor="ctr"/>
-          <a:lstStyle/>
-          <a:p>
-            <a:pPr algn="r" indent="0" marL="0">
-              <a:buNone/>
-            </a:pPr>
-            <a:r>
-              <a:rPr lang="en-US" sz="1400" b="1" dirty="0">
-                <a:solidFill>
-                  <a:schemeClr val="tx1"/>
-                </a:solidFill>
-              </a:rPr>
-              <a:t>$9,900</a:t>
-            </a:r>
-            <a:endParaRPr lang="en-US" sz="1400" dirty="0"/>
-          </a:p>
-        </p:txBody>
-      </p:sp>
-      <p:sp>
-        <p:nvSpPr>
-          <p:cNvPr id="18" name="Text 16"/>
-          <p:cNvSpPr txBox="1"/>
-          <p:nvPr/>
-        </p:nvSpPr>
-        <p:spPr>
-          <a:xfrm>
-            <a:off x="4251960" y="2898648"/>
-            <a:ext cx="4206240" cy="201168"/>
-          </a:xfrm>
-          <a:prstGeom prst="rect">
-            <a:avLst/>
-          </a:prstGeom>
-          <a:noFill/>
-          <a:ln/>
-        </p:spPr>
-        <p:txBody>
-          <a:bodyPr wrap="square" lIns="0" tIns="0" rIns="0" bIns="0" rtlCol="0" anchor="ctr"/>
-          <a:lstStyle/>
+              <a:t>We bill you monthly and work alongside Rob’s team on the project. Every month we sit down with you to check progress, review results and agree what comes next.</a:t>
+            </a:r>
+            <a:endParaRPr lang="en-US" sz="1200" dirty="0"/>
+          </a:p>
           <a:p>
             <a:pPr indent="0" marL="0">
-              <a:buNone/>
-            </a:pPr>
-            <a:r>
-              <a:rPr lang="en-US" sz="900" b="1" spc="100" kern="0" dirty="0">
+              <a:spcAft>
+                <a:spcPts val="400"/>
+              </a:spcAft>
+              <a:buNone/>
+            </a:pPr>
+            <a:r>
+              <a:rPr lang="en-US" sz="1200" dirty="0">
                 <a:solidFill>
                   <a:schemeClr val="accent3"/>
                 </a:solidFill>
               </a:rPr>
-              <a:t>RECOMMENDED 3-MONTH ROLLOUT</a:t>
-            </a:r>
-            <a:endParaRPr lang="en-US" sz="900" dirty="0"/>
-          </a:p>
-        </p:txBody>
-      </p:sp>
-      <p:sp>
-        <p:nvSpPr>
-          <p:cNvPr id="19" name="Text 17"/>
-          <p:cNvSpPr txBox="1"/>
-          <p:nvPr/>
-        </p:nvSpPr>
-        <p:spPr>
-          <a:xfrm>
-            <a:off x="4251960" y="3127248"/>
-            <a:ext cx="2743200" cy="274320"/>
-          </a:xfrm>
-          <a:prstGeom prst="rect">
-            <a:avLst/>
-          </a:prstGeom>
-          <a:noFill/>
-          <a:ln/>
-        </p:spPr>
-        <p:txBody>
-          <a:bodyPr wrap="square" lIns="0" tIns="0" rIns="0" bIns="0" rtlCol="0" anchor="ctr"/>
-          <a:lstStyle/>
-          <a:p>
-            <a:pPr indent="0" marL="0">
-              <a:buNone/>
-            </a:pPr>
-            <a:r>
-              <a:rPr lang="en-US" sz="1400" dirty="0">
-                <a:solidFill>
-                  <a:schemeClr val="tx1"/>
-                </a:solidFill>
-              </a:rPr>
-              <a:t>3 months x $9,000</a:t>
-            </a:r>
-            <a:endParaRPr lang="en-US" sz="1400" dirty="0"/>
-          </a:p>
-        </p:txBody>
-      </p:sp>
-      <p:sp>
-        <p:nvSpPr>
-          <p:cNvPr id="20" name="Text 18"/>
-          <p:cNvSpPr txBox="1"/>
-          <p:nvPr/>
-        </p:nvSpPr>
-        <p:spPr>
-          <a:xfrm>
-            <a:off x="6903720" y="3127248"/>
-            <a:ext cx="1508760" cy="274320"/>
-          </a:xfrm>
-          <a:prstGeom prst="rect">
-            <a:avLst/>
-          </a:prstGeom>
-          <a:noFill/>
-          <a:ln/>
-        </p:spPr>
-        <p:txBody>
-          <a:bodyPr wrap="square" lIns="0" tIns="0" rIns="0" bIns="0" rtlCol="0" anchor="ctr"/>
-          <a:lstStyle/>
-          <a:p>
-            <a:pPr algn="r" indent="0" marL="0">
-              <a:buNone/>
-            </a:pPr>
-            <a:r>
-              <a:rPr lang="en-US" sz="1400" dirty="0">
-                <a:solidFill>
-                  <a:schemeClr val="tx1"/>
-                </a:solidFill>
-              </a:rPr>
-              <a:t>$27,000</a:t>
-            </a:r>
-            <a:endParaRPr lang="en-US" sz="1400" dirty="0"/>
-          </a:p>
-        </p:txBody>
-      </p:sp>
-      <p:sp>
-        <p:nvSpPr>
-          <p:cNvPr id="21" name="Text 19"/>
-          <p:cNvSpPr txBox="1"/>
-          <p:nvPr/>
-        </p:nvSpPr>
-        <p:spPr>
-          <a:xfrm>
-            <a:off x="4251960" y="3419856"/>
-            <a:ext cx="2743200" cy="274320"/>
-          </a:xfrm>
-          <a:prstGeom prst="rect">
-            <a:avLst/>
-          </a:prstGeom>
-          <a:noFill/>
-          <a:ln/>
-        </p:spPr>
-        <p:txBody>
-          <a:bodyPr wrap="square" lIns="0" tIns="0" rIns="0" bIns="0" rtlCol="0" anchor="ctr"/>
-          <a:lstStyle/>
-          <a:p>
-            <a:pPr indent="0" marL="0">
-              <a:buNone/>
-            </a:pPr>
-            <a:r>
-              <a:rPr lang="en-US" sz="1400" dirty="0">
-                <a:solidFill>
-                  <a:schemeClr val="tx1"/>
-                </a:solidFill>
-              </a:rPr>
-              <a:t>GST (10%)</a:t>
-            </a:r>
-            <a:endParaRPr lang="en-US" sz="1400" dirty="0"/>
-          </a:p>
-        </p:txBody>
-      </p:sp>
-      <p:sp>
-        <p:nvSpPr>
-          <p:cNvPr id="22" name="Text 20"/>
-          <p:cNvSpPr txBox="1"/>
-          <p:nvPr/>
-        </p:nvSpPr>
-        <p:spPr>
-          <a:xfrm>
-            <a:off x="6903720" y="3419856"/>
-            <a:ext cx="1508760" cy="274320"/>
-          </a:xfrm>
-          <a:prstGeom prst="rect">
-            <a:avLst/>
-          </a:prstGeom>
-          <a:noFill/>
-          <a:ln/>
-        </p:spPr>
-        <p:txBody>
-          <a:bodyPr wrap="square" lIns="0" tIns="0" rIns="0" bIns="0" rtlCol="0" anchor="ctr"/>
-          <a:lstStyle/>
-          <a:p>
-            <a:pPr algn="r" indent="0" marL="0">
-              <a:buNone/>
-            </a:pPr>
-            <a:r>
-              <a:rPr lang="en-US" sz="1400" dirty="0">
-                <a:solidFill>
-                  <a:schemeClr val="tx1"/>
-                </a:solidFill>
-              </a:rPr>
-              <a:t>$2,700</a:t>
-            </a:r>
-            <a:endParaRPr lang="en-US" sz="1400" dirty="0"/>
-          </a:p>
-        </p:txBody>
-      </p:sp>
-      <p:sp>
-        <p:nvSpPr>
-          <p:cNvPr id="23" name="Shape 21"/>
-          <p:cNvSpPr/>
-          <p:nvPr/>
-        </p:nvSpPr>
-        <p:spPr>
-          <a:xfrm>
-            <a:off x="4251960" y="3739896"/>
-            <a:ext cx="4160520" cy="0"/>
-          </a:xfrm>
-          <a:prstGeom prst="line">
-            <a:avLst/>
-          </a:prstGeom>
-          <a:noFill/>
-          <a:ln w="9525">
-            <a:solidFill>
-              <a:schemeClr val="accent4"/>
-            </a:solidFill>
-            <a:prstDash val="solid"/>
-          </a:ln>
-        </p:spPr>
-      </p:sp>
-      <p:sp>
-        <p:nvSpPr>
-          <p:cNvPr id="24" name="Text 22"/>
-          <p:cNvSpPr txBox="1"/>
-          <p:nvPr/>
-        </p:nvSpPr>
-        <p:spPr>
-          <a:xfrm>
-            <a:off x="4251960" y="3813048"/>
-            <a:ext cx="2743200" cy="274320"/>
-          </a:xfrm>
-          <a:prstGeom prst="rect">
-            <a:avLst/>
-          </a:prstGeom>
-          <a:noFill/>
-          <a:ln/>
-        </p:spPr>
-        <p:txBody>
-          <a:bodyPr wrap="square" lIns="0" tIns="0" rIns="0" bIns="0" rtlCol="0" anchor="ctr"/>
-          <a:lstStyle/>
-          <a:p>
-            <a:pPr indent="0" marL="0">
-              <a:buNone/>
-            </a:pPr>
-            <a:r>
-              <a:rPr lang="en-US" sz="1400" b="1" dirty="0">
-                <a:solidFill>
-                  <a:schemeClr val="accent1"/>
-                </a:solidFill>
-              </a:rPr>
-              <a:t>Total for 3 months</a:t>
-            </a:r>
-            <a:endParaRPr lang="en-US" sz="1400" dirty="0"/>
-          </a:p>
-        </p:txBody>
-      </p:sp>
-      <p:sp>
-        <p:nvSpPr>
-          <p:cNvPr id="25" name="Text 23"/>
-          <p:cNvSpPr txBox="1"/>
-          <p:nvPr/>
-        </p:nvSpPr>
-        <p:spPr>
-          <a:xfrm>
-            <a:off x="6903720" y="3813048"/>
-            <a:ext cx="1508760" cy="274320"/>
-          </a:xfrm>
-          <a:prstGeom prst="rect">
-            <a:avLst/>
-          </a:prstGeom>
-          <a:noFill/>
-          <a:ln/>
-        </p:spPr>
-        <p:txBody>
-          <a:bodyPr wrap="square" lIns="0" tIns="0" rIns="0" bIns="0" rtlCol="0" anchor="ctr"/>
-          <a:lstStyle/>
-          <a:p>
-            <a:pPr algn="r" indent="0" marL="0">
-              <a:buNone/>
-            </a:pPr>
-            <a:r>
-              <a:rPr lang="en-US" sz="1400" b="1" dirty="0">
-                <a:solidFill>
-                  <a:schemeClr val="accent1"/>
-                </a:solidFill>
-              </a:rPr>
-              <a:t>$29,700</a:t>
-            </a:r>
-            <a:endParaRPr lang="en-US" sz="1400" dirty="0"/>
-          </a:p>
-        </p:txBody>
-      </p:sp>
-      <p:sp>
-        <p:nvSpPr>
-          <p:cNvPr id="26" name="Text 24"/>
-          <p:cNvSpPr txBox="1"/>
-          <p:nvPr/>
-        </p:nvSpPr>
-        <p:spPr>
-          <a:xfrm>
-            <a:off x="457200" y="4315968"/>
-            <a:ext cx="8229600" cy="384048"/>
-          </a:xfrm>
-          <a:prstGeom prst="rect">
-            <a:avLst/>
-          </a:prstGeom>
-          <a:noFill/>
-          <a:ln/>
-        </p:spPr>
-        <p:txBody>
-          <a:bodyPr wrap="square" lIns="0" tIns="0" rIns="0" bIns="0" rtlCol="0" anchor="ctr"/>
-          <a:lstStyle/>
-          <a:p>
-            <a:pPr indent="0" marL="0">
-              <a:buNone/>
-            </a:pPr>
-            <a:r>
-              <a:rPr lang="en-US" sz="1100" b="1" dirty="0">
-                <a:solidFill>
-                  <a:schemeClr val="tx2"/>
-                </a:solidFill>
-              </a:rPr>
-              <a:t>Covers your whole team of about 30: </a:t>
-            </a:r>
-            <a:pPr indent="0" marL="0">
-              <a:buNone/>
-            </a:pPr>
-            <a:r>
-              <a:rPr lang="en-US" sz="1100" dirty="0">
-                <a:solidFill>
-                  <a:schemeClr val="tx1"/>
-                </a:solidFill>
-              </a:rPr>
-              <a:t>kickoff, group training, a one-on-one setup for every person, the automations and ongoing support. Your software subscriptions are paid directly by you.</a:t>
-            </a:r>
-            <a:endParaRPr lang="en-US" sz="1100" dirty="0"/>
+              <a:t>Everything is built on your own accounts and logins, so you keep it all. You pay your own software subscriptions directly.</a:t>
+            </a:r>
+            <a:endParaRPr lang="en-US" sz="1200" dirty="0"/>
           </a:p>
         </p:txBody>
       </p:sp>

</xml_diff>

<commit_message>
Redesign pricing slide with call details and getting-started steps
Co-Authored-By: Claude Opus 5.5 <noreply@anthropic.com>
Claude-Session: https://claude.ai/code/session_01JFepqPwf7VWRrj19aSGkg1
</commit_message>
<xml_diff>
--- a/Fractional_AI_Partner_Pricing.pptx
+++ b/Fractional_AI_Partner_Pricing.pptx
@@ -108,12 +108,12 @@
   <p:extLst>
     <p:ext uri="{521415D9-36F7-43E2-AB2F-B90AF26B5E84}">
       <p14:sectionLst xmlns:p14="http://schemas.microsoft.com/office/powerpoint/2010/main">
-        <p14:section name="Pricing" id="{49164115-6995-de3d-8c69-d580a20b4bb3}">
+        <p14:section name="Pricing" id="{ce0d6cc1-9fe7-c19b-bce5-55ed993b6502}">
           <p14:sldIdLst>
             <p14:sldId id="256"/>
           </p14:sldIdLst>
         </p14:section>
-        <p14:section name="Process" id="{0492ffc6-b5b4-7d34-2e1c-f4e126d1917a}">
+        <p14:section name="Process" id="{e9a8af0c-2c1b-2959-492f-9f46650f0b23}">
           <p14:sldIdLst>
             <p14:sldId id="257"/>
           </p14:sldIdLst>
@@ -1248,7 +1248,7 @@
                   <a:schemeClr val="accent1"/>
                 </a:solidFill>
               </a:rPr>
-              <a:t>INVESTMENT</a:t>
+              <a:t>PRICING</a:t>
             </a:r>
             <a:endParaRPr lang="en-US" sz="1000" dirty="0"/>
           </a:p>
@@ -1289,7 +1289,7 @@
                 <a:ea typeface="Cambria" pitchFamily="34" charset="-122"/>
                 <a:cs typeface="Cambria" pitchFamily="34" charset="-120"/>
               </a:rPr>
-              <a:t>One price, everything included</a:t>
+              <a:t>Your investment</a:t>
             </a:r>
             <a:endParaRPr lang="en-US" sz="3000" dirty="0"/>
           </a:p>
@@ -1297,18 +1297,18 @@
       </p:sp>
       <p:sp>
         <p:nvSpPr>
-          <p:cNvPr id="4" name="Price panel"/>
+          <p:cNvPr id="4" name="Tile 1"/>
           <p:cNvSpPr/>
           <p:nvPr/>
         </p:nvSpPr>
         <p:spPr>
           <a:xfrm>
-            <a:off x="457200" y="1280160"/>
-            <a:ext cx="3017520" cy="2148840"/>
+            <a:off x="457200" y="1234440"/>
+            <a:ext cx="2651760" cy="868680"/>
           </a:xfrm>
           <a:prstGeom prst="roundRect">
             <a:avLst>
-              <a:gd name="adj" fmla="val 2553"/>
+              <a:gd name="adj" fmla="val 6316"/>
             </a:avLst>
           </a:prstGeom>
           <a:solidFill>
@@ -1330,8 +1330,8 @@
         </p:nvSpPr>
         <p:spPr>
           <a:xfrm>
-            <a:off x="731520" y="1463040"/>
-            <a:ext cx="2560320" cy="201168"/>
+            <a:off x="685800" y="1234440"/>
+            <a:ext cx="2286000" cy="868680"/>
           </a:xfrm>
           <a:prstGeom prst="rect">
             <a:avLst/>
@@ -1347,43 +1347,7 @@
               <a:buNone/>
             </a:pPr>
             <a:r>
-              <a:rPr lang="en-US" sz="900" b="1" spc="200" kern="0" dirty="0">
-                <a:solidFill>
-                  <a:schemeClr val="accent4"/>
-                </a:solidFill>
-              </a:rPr>
-              <a:t>INVESTMENT</a:t>
-            </a:r>
-            <a:endParaRPr lang="en-US" sz="900" dirty="0"/>
-          </a:p>
-        </p:txBody>
-      </p:sp>
-      <p:sp>
-        <p:nvSpPr>
-          <p:cNvPr id="6" name="Text 4"/>
-          <p:cNvSpPr txBox="1"/>
-          <p:nvPr/>
-        </p:nvSpPr>
-        <p:spPr>
-          <a:xfrm>
-            <a:off x="731520" y="1691640"/>
-            <a:ext cx="2651760" cy="731520"/>
-          </a:xfrm>
-          <a:prstGeom prst="rect">
-            <a:avLst/>
-          </a:prstGeom>
-          <a:noFill/>
-          <a:ln/>
-        </p:spPr>
-        <p:txBody>
-          <a:bodyPr wrap="square" lIns="0" tIns="0" rIns="0" bIns="0" rtlCol="0" anchor="b"/>
-          <a:lstStyle/>
-          <a:p>
-            <a:pPr indent="0" marL="0">
-              <a:buNone/>
-            </a:pPr>
-            <a:r>
-              <a:rPr lang="en-US" sz="4800" dirty="0">
+              <a:rPr lang="en-US" sz="3000" b="1" dirty="0">
                 <a:solidFill>
                   <a:schemeClr val="bg1"/>
                 </a:solidFill>
@@ -1391,132 +1355,40 @@
                 <a:ea typeface="Cambria" pitchFamily="34" charset="-122"/>
                 <a:cs typeface="Cambria" pitchFamily="34" charset="-120"/>
               </a:rPr>
-              <a:t>$9K</a:t>
-            </a:r>
+              <a:t>$9,000</a:t>
+            </a:r>
+            <a:endParaRPr lang="en-US" sz="3000" dirty="0"/>
+          </a:p>
+          <a:p>
             <a:pPr indent="0" marL="0">
               <a:buNone/>
             </a:pPr>
             <a:r>
-              <a:rPr lang="en-US" sz="1600" dirty="0">
-                <a:solidFill>
-                  <a:schemeClr val="bg1"/>
-                </a:solidFill>
-                <a:latin typeface="Cambria" pitchFamily="34" charset="0"/>
-                <a:ea typeface="Cambria" pitchFamily="34" charset="-122"/>
-                <a:cs typeface="Cambria" pitchFamily="34" charset="-120"/>
-              </a:rPr>
-              <a:t>  a month</a:t>
-            </a:r>
-            <a:endParaRPr lang="en-US" sz="4800" dirty="0"/>
-          </a:p>
-        </p:txBody>
-      </p:sp>
-      <p:sp>
-        <p:nvSpPr>
-          <p:cNvPr id="7" name="Text 5"/>
-          <p:cNvSpPr txBox="1"/>
-          <p:nvPr/>
-        </p:nvSpPr>
-        <p:spPr>
-          <a:xfrm>
-            <a:off x="731520" y="2514600"/>
-            <a:ext cx="2651760" cy="502920"/>
-          </a:xfrm>
-          <a:prstGeom prst="rect">
-            <a:avLst/>
-          </a:prstGeom>
-          <a:noFill/>
-          <a:ln/>
-        </p:spPr>
-        <p:txBody>
-          <a:bodyPr wrap="square" lIns="0" tIns="0" rIns="0" bIns="0" rtlCol="0" anchor="ctr"/>
-          <a:lstStyle/>
-          <a:p>
-            <a:pPr indent="0" marL="0">
-              <a:spcAft>
-                <a:spcPts val="200"/>
-              </a:spcAft>
-              <a:buNone/>
-            </a:pPr>
-            <a:r>
-              <a:rPr lang="en-US" sz="1300" dirty="0">
-                <a:solidFill>
-                  <a:schemeClr val="bg1"/>
-                </a:solidFill>
-              </a:rPr>
-              <a:t>plus GST</a:t>
-            </a:r>
-            <a:endParaRPr lang="en-US" sz="1300" dirty="0"/>
-          </a:p>
-          <a:p>
-            <a:pPr indent="0" marL="0">
-              <a:spcAft>
-                <a:spcPts val="200"/>
-              </a:spcAft>
-              <a:buNone/>
-            </a:pPr>
-            <a:r>
-              <a:rPr lang="en-US" sz="1300" dirty="0">
-                <a:solidFill>
-                  <a:schemeClr val="bg1"/>
-                </a:solidFill>
-              </a:rPr>
-              <a:t>Billed monthly by Outsourcing Angel</a:t>
-            </a:r>
-            <a:endParaRPr lang="en-US" sz="1300" dirty="0"/>
-          </a:p>
-        </p:txBody>
-      </p:sp>
-      <p:sp>
-        <p:nvSpPr>
-          <p:cNvPr id="8" name="Text 6"/>
-          <p:cNvSpPr txBox="1"/>
-          <p:nvPr/>
-        </p:nvSpPr>
-        <p:spPr>
-          <a:xfrm>
-            <a:off x="731520" y="3044952"/>
-            <a:ext cx="2651760" cy="228600"/>
-          </a:xfrm>
-          <a:prstGeom prst="rect">
-            <a:avLst/>
-          </a:prstGeom>
-          <a:noFill/>
-          <a:ln/>
-        </p:spPr>
-        <p:txBody>
-          <a:bodyPr wrap="square" lIns="0" tIns="0" rIns="0" bIns="0" rtlCol="0" anchor="ctr"/>
-          <a:lstStyle/>
-          <a:p>
-            <a:pPr indent="0" marL="0">
-              <a:buNone/>
-            </a:pPr>
-            <a:r>
-              <a:rPr lang="en-US" sz="1000" dirty="0">
+              <a:rPr lang="en-US" sz="1100" dirty="0">
                 <a:solidFill>
                   <a:schemeClr val="accent4"/>
                 </a:solidFill>
               </a:rPr>
-              <a:t>Month by month, reviewed together each month</a:t>
-            </a:r>
-            <a:endParaRPr lang="en-US" sz="1000" dirty="0"/>
-          </a:p>
-        </p:txBody>
-      </p:sp>
-      <p:sp>
-        <p:nvSpPr>
-          <p:cNvPr id="9" name="Included panel"/>
+              <a:t>a month + GST</a:t>
+            </a:r>
+            <a:endParaRPr lang="en-US" sz="3000" dirty="0"/>
+          </a:p>
+        </p:txBody>
+      </p:sp>
+      <p:sp>
+        <p:nvSpPr>
+          <p:cNvPr id="6" name="Tile 2"/>
           <p:cNvSpPr/>
           <p:nvPr/>
         </p:nvSpPr>
         <p:spPr>
           <a:xfrm>
-            <a:off x="3657600" y="1280160"/>
-            <a:ext cx="5029200" cy="2148840"/>
+            <a:off x="3246120" y="1234440"/>
+            <a:ext cx="2651760" cy="868680"/>
           </a:xfrm>
           <a:prstGeom prst="roundRect">
             <a:avLst>
-              <a:gd name="adj" fmla="val 2553"/>
+              <a:gd name="adj" fmla="val 6316"/>
             </a:avLst>
           </a:prstGeom>
           <a:solidFill>
@@ -1532,14 +1404,14 @@
       </p:sp>
       <p:sp>
         <p:nvSpPr>
-          <p:cNvPr id="10" name="Text 8"/>
+          <p:cNvPr id="7" name="Text 5"/>
           <p:cNvSpPr txBox="1"/>
           <p:nvPr/>
         </p:nvSpPr>
         <p:spPr>
           <a:xfrm>
-            <a:off x="3931920" y="1463040"/>
-            <a:ext cx="4572000" cy="201168"/>
+            <a:off x="3474720" y="1234440"/>
+            <a:ext cx="2286000" cy="868680"/>
           </a:xfrm>
           <a:prstGeom prst="rect">
             <a:avLst/>
@@ -1555,147 +1427,52 @@
               <a:buNone/>
             </a:pPr>
             <a:r>
-              <a:rPr lang="en-US" sz="1000" b="1" spc="200" kern="0" dirty="0">
-                <a:solidFill>
-                  <a:schemeClr val="accent1"/>
-                </a:solidFill>
-              </a:rPr>
-              <a:t>WHAT IS INCLUDED</a:t>
-            </a:r>
-            <a:endParaRPr lang="en-US" sz="1000" dirty="0"/>
-          </a:p>
-        </p:txBody>
-      </p:sp>
-      <p:sp>
-        <p:nvSpPr>
-          <p:cNvPr id="11" name="Text 9"/>
-          <p:cNvSpPr txBox="1"/>
-          <p:nvPr/>
-        </p:nvSpPr>
-        <p:spPr>
-          <a:xfrm>
-            <a:off x="3931920" y="1755648"/>
-            <a:ext cx="4572000" cy="1508760"/>
-          </a:xfrm>
-          <a:prstGeom prst="rect">
-            <a:avLst/>
-          </a:prstGeom>
-          <a:noFill/>
-          <a:ln/>
-        </p:spPr>
-        <p:txBody>
-          <a:bodyPr wrap="square" lIns="0" tIns="0" rIns="0" bIns="0" rtlCol="0" anchor="t"/>
-          <a:lstStyle/>
-          <a:p>
-            <a:pPr marL="177800" indent="-177800">
-              <a:spcAft>
-                <a:spcPts val="500"/>
-              </a:spcAft>
-              <a:buSzPct val="100000"/>
-              <a:buChar char="•"/>
-            </a:pPr>
-            <a:r>
-              <a:rPr lang="en-US" sz="1300" dirty="0">
-                <a:solidFill>
-                  <a:schemeClr val="tx1"/>
-                </a:solidFill>
-              </a:rPr>
-              <a:t>A one-on-one session for every person on the team</a:t>
-            </a:r>
-            <a:endParaRPr lang="en-US" sz="1300" dirty="0"/>
-          </a:p>
-          <a:p>
-            <a:pPr marL="177800" indent="-177800">
-              <a:spcAft>
-                <a:spcPts val="500"/>
-              </a:spcAft>
-              <a:buSzPct val="100000"/>
-              <a:buChar char="•"/>
-            </a:pPr>
-            <a:r>
-              <a:rPr lang="en-US" sz="1300" dirty="0">
-                <a:solidFill>
-                  <a:schemeClr val="tx1"/>
-                </a:solidFill>
-              </a:rPr>
-              <a:t>Group training and 4 or 5 team meetings</a:t>
-            </a:r>
-            <a:endParaRPr lang="en-US" sz="1300" dirty="0"/>
-          </a:p>
-          <a:p>
-            <a:pPr marL="177800" indent="-177800">
-              <a:spcAft>
-                <a:spcPts val="500"/>
-              </a:spcAft>
-              <a:buSzPct val="100000"/>
-              <a:buChar char="•"/>
-            </a:pPr>
-            <a:r>
-              <a:rPr lang="en-US" sz="1300" dirty="0">
-                <a:solidFill>
-                  <a:schemeClr val="tx1"/>
-                </a:solidFill>
-              </a:rPr>
-              <a:t>The automations, including the progress payment agent</a:t>
-            </a:r>
-            <a:endParaRPr lang="en-US" sz="1300" dirty="0"/>
-          </a:p>
-          <a:p>
-            <a:pPr marL="177800" indent="-177800">
-              <a:spcAft>
-                <a:spcPts val="500"/>
-              </a:spcAft>
-              <a:buSzPct val="100000"/>
-              <a:buChar char="•"/>
-            </a:pPr>
-            <a:r>
-              <a:rPr lang="en-US" sz="1300" dirty="0">
-                <a:solidFill>
-                  <a:schemeClr val="tx1"/>
-                </a:solidFill>
-              </a:rPr>
-              <a:t>Support and ongoing improvement</a:t>
-            </a:r>
-            <a:endParaRPr lang="en-US" sz="1300" dirty="0"/>
-          </a:p>
-          <a:p>
-            <a:pPr marL="177800" indent="-177800">
-              <a:spcAft>
-                <a:spcPts val="500"/>
-              </a:spcAft>
-              <a:buSzPct val="100000"/>
-              <a:buChar char="•"/>
-            </a:pPr>
-            <a:r>
-              <a:rPr lang="en-US" sz="1300" dirty="0">
-                <a:solidFill>
-                  <a:schemeClr val="tx1"/>
-                </a:solidFill>
-              </a:rPr>
-              <a:t>A monthly check-in with Outsourcing Angel</a:t>
-            </a:r>
-            <a:endParaRPr lang="en-US" sz="1300" dirty="0"/>
-          </a:p>
-        </p:txBody>
-      </p:sp>
-      <p:sp>
-        <p:nvSpPr>
-          <p:cNvPr id="12" name="Partner note"/>
+              <a:rPr lang="en-US" sz="2000" b="1" dirty="0">
+                <a:solidFill>
+                  <a:schemeClr val="tx2"/>
+                </a:solidFill>
+                <a:latin typeface="Cambria" pitchFamily="34" charset="0"/>
+                <a:ea typeface="Cambria" pitchFamily="34" charset="-122"/>
+                <a:cs typeface="Cambria" pitchFamily="34" charset="-120"/>
+              </a:rPr>
+              <a:t>About 30 people</a:t>
+            </a:r>
+            <a:endParaRPr lang="en-US" sz="2000" dirty="0"/>
+          </a:p>
+          <a:p>
+            <a:pPr indent="0" marL="0">
+              <a:buNone/>
+            </a:pPr>
+            <a:r>
+              <a:rPr lang="en-US" sz="1100" dirty="0">
+                <a:solidFill>
+                  <a:schemeClr val="accent3"/>
+                </a:solidFill>
+              </a:rPr>
+              <a:t>Every person set up one-on-one</a:t>
+            </a:r>
+            <a:endParaRPr lang="en-US" sz="2000" dirty="0"/>
+          </a:p>
+        </p:txBody>
+      </p:sp>
+      <p:sp>
+        <p:nvSpPr>
+          <p:cNvPr id="8" name="Tile 3"/>
           <p:cNvSpPr/>
           <p:nvPr/>
         </p:nvSpPr>
         <p:spPr>
           <a:xfrm>
-            <a:off x="457200" y="3611880"/>
-            <a:ext cx="8229600" cy="1005840"/>
+            <a:off x="6035040" y="1234440"/>
+            <a:ext cx="2651760" cy="868680"/>
           </a:xfrm>
           <a:prstGeom prst="roundRect">
             <a:avLst>
-              <a:gd name="adj" fmla="val 5455"/>
+              <a:gd name="adj" fmla="val 6316"/>
             </a:avLst>
           </a:prstGeom>
           <a:solidFill>
-            <a:schemeClr val="accent2"/>
+            <a:schemeClr val="bg1"/>
           </a:solidFill>
           <a:ln w="12700">
             <a:solidFill>
@@ -1707,14 +1484,14 @@
       </p:sp>
       <p:sp>
         <p:nvSpPr>
-          <p:cNvPr id="13" name="Text 11"/>
+          <p:cNvPr id="9" name="Text 7"/>
           <p:cNvSpPr txBox="1"/>
           <p:nvPr/>
         </p:nvSpPr>
         <p:spPr>
           <a:xfrm>
-            <a:off x="685800" y="3703320"/>
-            <a:ext cx="7772400" cy="822960"/>
+            <a:off x="6263640" y="1234440"/>
+            <a:ext cx="2286000" cy="868680"/>
           </a:xfrm>
           <a:prstGeom prst="rect">
             <a:avLst/>
@@ -1727,51 +1504,718 @@
           <a:lstStyle/>
           <a:p>
             <a:pPr indent="0" marL="0">
+              <a:buNone/>
+            </a:pPr>
+            <a:r>
+              <a:rPr lang="en-US" sz="2000" b="1" dirty="0">
+                <a:solidFill>
+                  <a:schemeClr val="tx2"/>
+                </a:solidFill>
+                <a:latin typeface="Cambria" pitchFamily="34" charset="0"/>
+                <a:ea typeface="Cambria" pitchFamily="34" charset="-122"/>
+                <a:cs typeface="Cambria" pitchFamily="34" charset="-120"/>
+              </a:rPr>
+              <a:t>Month by month</a:t>
+            </a:r>
+            <a:endParaRPr lang="en-US" sz="2000" dirty="0"/>
+          </a:p>
+          <a:p>
+            <a:pPr indent="0" marL="0">
+              <a:buNone/>
+            </a:pPr>
+            <a:r>
+              <a:rPr lang="en-US" sz="1100" dirty="0">
+                <a:solidFill>
+                  <a:schemeClr val="accent3"/>
+                </a:solidFill>
+              </a:rPr>
+              <a:t>Reviewed with you, no lock-in</a:t>
+            </a:r>
+            <a:endParaRPr lang="en-US" sz="2000" dirty="0"/>
+          </a:p>
+        </p:txBody>
+      </p:sp>
+      <p:sp>
+        <p:nvSpPr>
+          <p:cNvPr id="10" name="Sized for your team"/>
+          <p:cNvSpPr/>
+          <p:nvPr/>
+        </p:nvSpPr>
+        <p:spPr>
+          <a:xfrm>
+            <a:off x="457200" y="2240280"/>
+            <a:ext cx="4046220" cy="1508760"/>
+          </a:xfrm>
+          <a:prstGeom prst="roundRect">
+            <a:avLst>
+              <a:gd name="adj" fmla="val 3636"/>
+            </a:avLst>
+          </a:prstGeom>
+          <a:solidFill>
+            <a:schemeClr val="bg1"/>
+          </a:solidFill>
+          <a:ln w="12700">
+            <a:solidFill>
+              <a:schemeClr val="accent6"/>
+            </a:solidFill>
+            <a:prstDash val="solid"/>
+          </a:ln>
+        </p:spPr>
+      </p:sp>
+      <p:sp>
+        <p:nvSpPr>
+          <p:cNvPr id="11" name="Text 9"/>
+          <p:cNvSpPr txBox="1"/>
+          <p:nvPr/>
+        </p:nvSpPr>
+        <p:spPr>
+          <a:xfrm>
+            <a:off x="685800" y="2377440"/>
+            <a:ext cx="3680460" cy="201168"/>
+          </a:xfrm>
+          <a:prstGeom prst="rect">
+            <a:avLst/>
+          </a:prstGeom>
+          <a:noFill/>
+          <a:ln/>
+        </p:spPr>
+        <p:txBody>
+          <a:bodyPr wrap="square" lIns="0" tIns="0" rIns="0" bIns="0" rtlCol="0" anchor="ctr"/>
+          <a:lstStyle/>
+          <a:p>
+            <a:pPr indent="0" marL="0">
+              <a:buNone/>
+            </a:pPr>
+            <a:r>
+              <a:rPr lang="en-US" sz="900" b="1" spc="200" kern="0" dirty="0">
+                <a:solidFill>
+                  <a:schemeClr val="accent1"/>
+                </a:solidFill>
+              </a:rPr>
+              <a:t>SIZED FOR YOUR TEAM</a:t>
+            </a:r>
+            <a:endParaRPr lang="en-US" sz="900" dirty="0"/>
+          </a:p>
+        </p:txBody>
+      </p:sp>
+      <p:sp>
+        <p:nvSpPr>
+          <p:cNvPr id="12" name="Text 10"/>
+          <p:cNvSpPr txBox="1"/>
+          <p:nvPr/>
+        </p:nvSpPr>
+        <p:spPr>
+          <a:xfrm>
+            <a:off x="685800" y="2651760"/>
+            <a:ext cx="3634740" cy="1005840"/>
+          </a:xfrm>
+          <a:prstGeom prst="rect">
+            <a:avLst/>
+          </a:prstGeom>
+          <a:noFill/>
+          <a:ln/>
+        </p:spPr>
+        <p:txBody>
+          <a:bodyPr wrap="square" lIns="0" tIns="0" rIns="0" bIns="0" rtlCol="0" anchor="t"/>
+          <a:lstStyle/>
+          <a:p>
+            <a:pPr marL="152400" indent="-152400">
               <a:spcAft>
                 <a:spcPts val="400"/>
               </a:spcAft>
-              <a:buNone/>
-            </a:pPr>
-            <a:r>
-              <a:rPr lang="en-US" sz="1200" b="1" dirty="0">
-                <a:solidFill>
-                  <a:schemeClr val="tx2"/>
-                </a:solidFill>
-              </a:rPr>
-              <a:t>Outsourcing Angel is with you the whole way. </a:t>
-            </a:r>
-            <a:pPr indent="0" marL="0">
+              <a:buSzPct val="100000"/>
+              <a:buChar char="•"/>
+            </a:pPr>
+            <a:r>
+              <a:rPr lang="en-US" sz="1150" dirty="0">
+                <a:solidFill>
+                  <a:schemeClr val="tx1"/>
+                </a:solidFill>
+              </a:rPr>
+              <a:t>A 2-hour one-on-one setup for every person</a:t>
+            </a:r>
+            <a:endParaRPr lang="en-US" sz="1150" dirty="0"/>
+          </a:p>
+          <a:p>
+            <a:pPr marL="152400" indent="-152400">
               <a:spcAft>
                 <a:spcPts val="400"/>
               </a:spcAft>
-              <a:buNone/>
-            </a:pPr>
-            <a:r>
-              <a:rPr lang="en-US" sz="1200" dirty="0">
+              <a:buSzPct val="100000"/>
+              <a:buChar char="•"/>
+            </a:pPr>
+            <a:r>
+              <a:rPr lang="en-US" sz="1150" dirty="0">
                 <a:solidFill>
                   <a:schemeClr val="tx1"/>
                 </a:solidFill>
               </a:rPr>
-              <a:t>We bill you monthly and work alongside Rob’s team on the project. Every month we sit down with you to check progress, review results and agree what comes next.</a:t>
-            </a:r>
-            <a:endParaRPr lang="en-US" sz="1200" dirty="0"/>
-          </a:p>
-          <a:p>
-            <a:pPr indent="0" marL="0">
+              <a:t>Group training in 4 to 5 teams</a:t>
+            </a:r>
+            <a:endParaRPr lang="en-US" sz="1150" dirty="0"/>
+          </a:p>
+          <a:p>
+            <a:pPr marL="152400" indent="-152400">
               <a:spcAft>
                 <a:spcPts val="400"/>
               </a:spcAft>
-              <a:buNone/>
-            </a:pPr>
-            <a:r>
-              <a:rPr lang="en-US" sz="1200" dirty="0">
+              <a:buSzPct val="100000"/>
+              <a:buChar char="•"/>
+            </a:pPr>
+            <a:r>
+              <a:rPr lang="en-US" sz="1150" dirty="0">
+                <a:solidFill>
+                  <a:schemeClr val="tx1"/>
+                </a:solidFill>
+              </a:rPr>
+              <a:t>Your developers set up and enabled</a:t>
+            </a:r>
+            <a:endParaRPr lang="en-US" sz="1150" dirty="0"/>
+          </a:p>
+          <a:p>
+            <a:pPr marL="152400" indent="-152400">
+              <a:spcAft>
+                <a:spcPts val="400"/>
+              </a:spcAft>
+              <a:buSzPct val="100000"/>
+              <a:buChar char="•"/>
+            </a:pPr>
+            <a:r>
+              <a:rPr lang="en-US" sz="1150" dirty="0">
+                <a:solidFill>
+                  <a:schemeClr val="tx1"/>
+                </a:solidFill>
+              </a:rPr>
+              <a:t>We start with the department that gives the best return</a:t>
+            </a:r>
+            <a:endParaRPr lang="en-US" sz="1150" dirty="0"/>
+          </a:p>
+        </p:txBody>
+      </p:sp>
+      <p:sp>
+        <p:nvSpPr>
+          <p:cNvPr id="13" name="Outsourcing Angel role"/>
+          <p:cNvSpPr/>
+          <p:nvPr/>
+        </p:nvSpPr>
+        <p:spPr>
+          <a:xfrm>
+            <a:off x="4640580" y="2240280"/>
+            <a:ext cx="4046220" cy="1508760"/>
+          </a:xfrm>
+          <a:prstGeom prst="roundRect">
+            <a:avLst>
+              <a:gd name="adj" fmla="val 3636"/>
+            </a:avLst>
+          </a:prstGeom>
+          <a:solidFill>
+            <a:schemeClr val="accent2"/>
+          </a:solidFill>
+          <a:ln w="12700">
+            <a:solidFill>
+              <a:schemeClr val="accent6"/>
+            </a:solidFill>
+            <a:prstDash val="solid"/>
+          </a:ln>
+        </p:spPr>
+      </p:sp>
+      <p:sp>
+        <p:nvSpPr>
+          <p:cNvPr id="14" name="Text 12"/>
+          <p:cNvSpPr txBox="1"/>
+          <p:nvPr/>
+        </p:nvSpPr>
+        <p:spPr>
+          <a:xfrm>
+            <a:off x="4869180" y="2377440"/>
+            <a:ext cx="3680460" cy="201168"/>
+          </a:xfrm>
+          <a:prstGeom prst="rect">
+            <a:avLst/>
+          </a:prstGeom>
+          <a:noFill/>
+          <a:ln/>
+        </p:spPr>
+        <p:txBody>
+          <a:bodyPr wrap="square" lIns="0" tIns="0" rIns="0" bIns="0" rtlCol="0" anchor="ctr"/>
+          <a:lstStyle/>
+          <a:p>
+            <a:pPr indent="0" marL="0">
+              <a:buNone/>
+            </a:pPr>
+            <a:r>
+              <a:rPr lang="en-US" sz="900" b="1" spc="200" kern="0" dirty="0">
+                <a:solidFill>
+                  <a:schemeClr val="accent1"/>
+                </a:solidFill>
+              </a:rPr>
+              <a:t>OUTSOURCING ANGEL’S ROLE</a:t>
+            </a:r>
+            <a:endParaRPr lang="en-US" sz="900" dirty="0"/>
+          </a:p>
+        </p:txBody>
+      </p:sp>
+      <p:sp>
+        <p:nvSpPr>
+          <p:cNvPr id="15" name="Text 13"/>
+          <p:cNvSpPr txBox="1"/>
+          <p:nvPr/>
+        </p:nvSpPr>
+        <p:spPr>
+          <a:xfrm>
+            <a:off x="4869180" y="2651760"/>
+            <a:ext cx="3634740" cy="1005840"/>
+          </a:xfrm>
+          <a:prstGeom prst="rect">
+            <a:avLst/>
+          </a:prstGeom>
+          <a:noFill/>
+          <a:ln/>
+        </p:spPr>
+        <p:txBody>
+          <a:bodyPr wrap="square" lIns="0" tIns="0" rIns="0" bIns="0" rtlCol="0" anchor="t"/>
+          <a:lstStyle/>
+          <a:p>
+            <a:pPr indent="0" marL="0">
+              <a:spcAft>
+                <a:spcPts val="600"/>
+              </a:spcAft>
+              <a:buNone/>
+            </a:pPr>
+            <a:r>
+              <a:rPr lang="en-US" sz="1150" dirty="0">
+                <a:solidFill>
+                  <a:schemeClr val="tx1"/>
+                </a:solidFill>
+              </a:rPr>
+              <a:t>We bill you monthly and stay with the project alongside Rob’s team. Each month we meet with you to check progress and agree the next priority.</a:t>
+            </a:r>
+            <a:endParaRPr lang="en-US" sz="1150" dirty="0"/>
+          </a:p>
+          <a:p>
+            <a:pPr indent="0" marL="0">
+              <a:spcAft>
+                <a:spcPts val="600"/>
+              </a:spcAft>
+              <a:buNone/>
+            </a:pPr>
+            <a:r>
+              <a:rPr lang="en-US" sz="1150" dirty="0">
                 <a:solidFill>
                   <a:schemeClr val="accent3"/>
                 </a:solidFill>
               </a:rPr>
-              <a:t>Everything is built on your own accounts and logins, so you keep it all. You pay your own software subscriptions directly.</a:t>
-            </a:r>
-            <a:endParaRPr lang="en-US" sz="1200" dirty="0"/>
+              <a:t>Everything is built on your own accounts and logins, so you keep it all.</a:t>
+            </a:r>
+            <a:endParaRPr lang="en-US" sz="1150" dirty="0"/>
+          </a:p>
+        </p:txBody>
+      </p:sp>
+      <p:sp>
+        <p:nvSpPr>
+          <p:cNvPr id="16" name="Text 14"/>
+          <p:cNvSpPr txBox="1"/>
+          <p:nvPr/>
+        </p:nvSpPr>
+        <p:spPr>
+          <a:xfrm>
+            <a:off x="457200" y="3886200"/>
+            <a:ext cx="1188720" cy="731520"/>
+          </a:xfrm>
+          <a:prstGeom prst="rect">
+            <a:avLst/>
+          </a:prstGeom>
+          <a:noFill/>
+          <a:ln/>
+        </p:spPr>
+        <p:txBody>
+          <a:bodyPr wrap="square" lIns="0" tIns="0" rIns="0" bIns="0" rtlCol="0" anchor="ctr"/>
+          <a:lstStyle/>
+          <a:p>
+            <a:pPr indent="0" marL="0">
+              <a:buNone/>
+            </a:pPr>
+            <a:r>
+              <a:rPr lang="en-US" sz="900" b="1" spc="100" kern="0" dirty="0">
+                <a:solidFill>
+                  <a:schemeClr val="accent1"/>
+                </a:solidFill>
+              </a:rPr>
+              <a:t>GETTING STARTED</a:t>
+            </a:r>
+            <a:endParaRPr lang="en-US" sz="900" dirty="0"/>
+          </a:p>
+        </p:txBody>
+      </p:sp>
+      <p:sp>
+        <p:nvSpPr>
+          <p:cNvPr id="17" name="Start 1 badge"/>
+          <p:cNvSpPr/>
+          <p:nvPr/>
+        </p:nvSpPr>
+        <p:spPr>
+          <a:xfrm>
+            <a:off x="1691640" y="4069080"/>
+            <a:ext cx="365760" cy="365760"/>
+          </a:xfrm>
+          <a:prstGeom prst="ellipse">
+            <a:avLst/>
+          </a:prstGeom>
+          <a:solidFill>
+            <a:schemeClr val="accent1"/>
+          </a:solidFill>
+          <a:ln w="12700">
+            <a:solidFill>
+              <a:schemeClr val="accent1"/>
+            </a:solidFill>
+            <a:prstDash val="solid"/>
+          </a:ln>
+        </p:spPr>
+      </p:sp>
+      <p:sp>
+        <p:nvSpPr>
+          <p:cNvPr id="18" name="Text 16"/>
+          <p:cNvSpPr txBox="1"/>
+          <p:nvPr/>
+        </p:nvSpPr>
+        <p:spPr>
+          <a:xfrm>
+            <a:off x="1691640" y="4069080"/>
+            <a:ext cx="365760" cy="365760"/>
+          </a:xfrm>
+          <a:prstGeom prst="rect">
+            <a:avLst/>
+          </a:prstGeom>
+          <a:noFill/>
+          <a:ln/>
+        </p:spPr>
+        <p:txBody>
+          <a:bodyPr wrap="square" lIns="0" tIns="0" rIns="0" bIns="0" rtlCol="0" anchor="ctr"/>
+          <a:lstStyle/>
+          <a:p>
+            <a:pPr algn="ctr" indent="0" marL="0">
+              <a:buNone/>
+            </a:pPr>
+            <a:r>
+              <a:rPr lang="en-US" sz="1400" b="1" dirty="0">
+                <a:solidFill>
+                  <a:schemeClr val="bg1"/>
+                </a:solidFill>
+                <a:latin typeface="Cambria" pitchFamily="34" charset="0"/>
+                <a:ea typeface="Cambria" pitchFamily="34" charset="-122"/>
+                <a:cs typeface="Cambria" pitchFamily="34" charset="-120"/>
+              </a:rPr>
+              <a:t>1</a:t>
+            </a:r>
+            <a:endParaRPr lang="en-US" sz="1400" dirty="0"/>
+          </a:p>
+        </p:txBody>
+      </p:sp>
+      <p:sp>
+        <p:nvSpPr>
+          <p:cNvPr id="19" name="Text 17"/>
+          <p:cNvSpPr txBox="1"/>
+          <p:nvPr/>
+        </p:nvSpPr>
+        <p:spPr>
+          <a:xfrm>
+            <a:off x="2148840" y="3886200"/>
+            <a:ext cx="1691640" cy="731520"/>
+          </a:xfrm>
+          <a:prstGeom prst="rect">
+            <a:avLst/>
+          </a:prstGeom>
+          <a:noFill/>
+          <a:ln/>
+        </p:spPr>
+        <p:txBody>
+          <a:bodyPr wrap="square" lIns="0" tIns="0" rIns="0" bIns="0" rtlCol="0" anchor="ctr"/>
+          <a:lstStyle/>
+          <a:p>
+            <a:pPr indent="0" marL="0">
+              <a:buNone/>
+            </a:pPr>
+            <a:r>
+              <a:rPr lang="en-US" sz="1150" dirty="0">
+                <a:solidFill>
+                  <a:schemeClr val="tx1"/>
+                </a:solidFill>
+              </a:rPr>
+              <a:t>You give us the go-ahead</a:t>
+            </a:r>
+            <a:endParaRPr lang="en-US" sz="1150" dirty="0"/>
+          </a:p>
+        </p:txBody>
+      </p:sp>
+      <p:sp>
+        <p:nvSpPr>
+          <p:cNvPr id="20" name="Text 18"/>
+          <p:cNvSpPr txBox="1"/>
+          <p:nvPr/>
+        </p:nvSpPr>
+        <p:spPr>
+          <a:xfrm>
+            <a:off x="3840480" y="3886200"/>
+            <a:ext cx="274320" cy="731520"/>
+          </a:xfrm>
+          <a:prstGeom prst="rect">
+            <a:avLst/>
+          </a:prstGeom>
+          <a:noFill/>
+          <a:ln/>
+        </p:spPr>
+        <p:txBody>
+          <a:bodyPr wrap="square" lIns="0" tIns="0" rIns="0" bIns="0" rtlCol="0" anchor="ctr"/>
+          <a:lstStyle/>
+          <a:p>
+            <a:pPr algn="ctr" indent="0" marL="0">
+              <a:buNone/>
+            </a:pPr>
+            <a:r>
+              <a:rPr lang="en-US" sz="1400" dirty="0">
+                <a:solidFill>
+                  <a:schemeClr val="accent1"/>
+                </a:solidFill>
+              </a:rPr>
+              <a:t>→</a:t>
+            </a:r>
+            <a:endParaRPr lang="en-US" sz="1400" dirty="0"/>
+          </a:p>
+        </p:txBody>
+      </p:sp>
+      <p:sp>
+        <p:nvSpPr>
+          <p:cNvPr id="21" name="Start 2 badge"/>
+          <p:cNvSpPr/>
+          <p:nvPr/>
+        </p:nvSpPr>
+        <p:spPr>
+          <a:xfrm>
+            <a:off x="4114800" y="4069080"/>
+            <a:ext cx="365760" cy="365760"/>
+          </a:xfrm>
+          <a:prstGeom prst="ellipse">
+            <a:avLst/>
+          </a:prstGeom>
+          <a:solidFill>
+            <a:schemeClr val="accent1"/>
+          </a:solidFill>
+          <a:ln w="12700">
+            <a:solidFill>
+              <a:schemeClr val="accent1"/>
+            </a:solidFill>
+            <a:prstDash val="solid"/>
+          </a:ln>
+        </p:spPr>
+      </p:sp>
+      <p:sp>
+        <p:nvSpPr>
+          <p:cNvPr id="22" name="Text 20"/>
+          <p:cNvSpPr txBox="1"/>
+          <p:nvPr/>
+        </p:nvSpPr>
+        <p:spPr>
+          <a:xfrm>
+            <a:off x="4114800" y="4069080"/>
+            <a:ext cx="365760" cy="365760"/>
+          </a:xfrm>
+          <a:prstGeom prst="rect">
+            <a:avLst/>
+          </a:prstGeom>
+          <a:noFill/>
+          <a:ln/>
+        </p:spPr>
+        <p:txBody>
+          <a:bodyPr wrap="square" lIns="0" tIns="0" rIns="0" bIns="0" rtlCol="0" anchor="ctr"/>
+          <a:lstStyle/>
+          <a:p>
+            <a:pPr algn="ctr" indent="0" marL="0">
+              <a:buNone/>
+            </a:pPr>
+            <a:r>
+              <a:rPr lang="en-US" sz="1400" b="1" dirty="0">
+                <a:solidFill>
+                  <a:schemeClr val="bg1"/>
+                </a:solidFill>
+                <a:latin typeface="Cambria" pitchFamily="34" charset="0"/>
+                <a:ea typeface="Cambria" pitchFamily="34" charset="-122"/>
+                <a:cs typeface="Cambria" pitchFamily="34" charset="-120"/>
+              </a:rPr>
+              <a:t>2</a:t>
+            </a:r>
+            <a:endParaRPr lang="en-US" sz="1400" dirty="0"/>
+          </a:p>
+        </p:txBody>
+      </p:sp>
+      <p:sp>
+        <p:nvSpPr>
+          <p:cNvPr id="23" name="Text 21"/>
+          <p:cNvSpPr txBox="1"/>
+          <p:nvPr/>
+        </p:nvSpPr>
+        <p:spPr>
+          <a:xfrm>
+            <a:off x="4572000" y="3886200"/>
+            <a:ext cx="1691640" cy="731520"/>
+          </a:xfrm>
+          <a:prstGeom prst="rect">
+            <a:avLst/>
+          </a:prstGeom>
+          <a:noFill/>
+          <a:ln/>
+        </p:spPr>
+        <p:txBody>
+          <a:bodyPr wrap="square" lIns="0" tIns="0" rIns="0" bIns="0" rtlCol="0" anchor="ctr"/>
+          <a:lstStyle/>
+          <a:p>
+            <a:pPr indent="0" marL="0">
+              <a:buNone/>
+            </a:pPr>
+            <a:r>
+              <a:rPr lang="en-US" sz="1150" dirty="0">
+                <a:solidFill>
+                  <a:schemeClr val="tx1"/>
+                </a:solidFill>
+              </a:rPr>
+              <a:t>We invoice the first month: $9,900 incl. GST</a:t>
+            </a:r>
+            <a:endParaRPr lang="en-US" sz="1150" dirty="0"/>
+          </a:p>
+        </p:txBody>
+      </p:sp>
+      <p:sp>
+        <p:nvSpPr>
+          <p:cNvPr id="24" name="Text 22"/>
+          <p:cNvSpPr txBox="1"/>
+          <p:nvPr/>
+        </p:nvSpPr>
+        <p:spPr>
+          <a:xfrm>
+            <a:off x="6263640" y="3886200"/>
+            <a:ext cx="274320" cy="731520"/>
+          </a:xfrm>
+          <a:prstGeom prst="rect">
+            <a:avLst/>
+          </a:prstGeom>
+          <a:noFill/>
+          <a:ln/>
+        </p:spPr>
+        <p:txBody>
+          <a:bodyPr wrap="square" lIns="0" tIns="0" rIns="0" bIns="0" rtlCol="0" anchor="ctr"/>
+          <a:lstStyle/>
+          <a:p>
+            <a:pPr algn="ctr" indent="0" marL="0">
+              <a:buNone/>
+            </a:pPr>
+            <a:r>
+              <a:rPr lang="en-US" sz="1400" dirty="0">
+                <a:solidFill>
+                  <a:schemeClr val="accent1"/>
+                </a:solidFill>
+              </a:rPr>
+              <a:t>→</a:t>
+            </a:r>
+            <a:endParaRPr lang="en-US" sz="1400" dirty="0"/>
+          </a:p>
+        </p:txBody>
+      </p:sp>
+      <p:sp>
+        <p:nvSpPr>
+          <p:cNvPr id="25" name="Start 3 badge"/>
+          <p:cNvSpPr/>
+          <p:nvPr/>
+        </p:nvSpPr>
+        <p:spPr>
+          <a:xfrm>
+            <a:off x="6537960" y="4069080"/>
+            <a:ext cx="365760" cy="365760"/>
+          </a:xfrm>
+          <a:prstGeom prst="ellipse">
+            <a:avLst/>
+          </a:prstGeom>
+          <a:solidFill>
+            <a:schemeClr val="accent1"/>
+          </a:solidFill>
+          <a:ln w="12700">
+            <a:solidFill>
+              <a:schemeClr val="accent1"/>
+            </a:solidFill>
+            <a:prstDash val="solid"/>
+          </a:ln>
+        </p:spPr>
+      </p:sp>
+      <p:sp>
+        <p:nvSpPr>
+          <p:cNvPr id="26" name="Text 24"/>
+          <p:cNvSpPr txBox="1"/>
+          <p:nvPr/>
+        </p:nvSpPr>
+        <p:spPr>
+          <a:xfrm>
+            <a:off x="6537960" y="4069080"/>
+            <a:ext cx="365760" cy="365760"/>
+          </a:xfrm>
+          <a:prstGeom prst="rect">
+            <a:avLst/>
+          </a:prstGeom>
+          <a:noFill/>
+          <a:ln/>
+        </p:spPr>
+        <p:txBody>
+          <a:bodyPr wrap="square" lIns="0" tIns="0" rIns="0" bIns="0" rtlCol="0" anchor="ctr"/>
+          <a:lstStyle/>
+          <a:p>
+            <a:pPr algn="ctr" indent="0" marL="0">
+              <a:buNone/>
+            </a:pPr>
+            <a:r>
+              <a:rPr lang="en-US" sz="1400" b="1" dirty="0">
+                <a:solidFill>
+                  <a:schemeClr val="bg1"/>
+                </a:solidFill>
+                <a:latin typeface="Cambria" pitchFamily="34" charset="0"/>
+                <a:ea typeface="Cambria" pitchFamily="34" charset="-122"/>
+                <a:cs typeface="Cambria" pitchFamily="34" charset="-120"/>
+              </a:rPr>
+              <a:t>3</a:t>
+            </a:r>
+            <a:endParaRPr lang="en-US" sz="1400" dirty="0"/>
+          </a:p>
+        </p:txBody>
+      </p:sp>
+      <p:sp>
+        <p:nvSpPr>
+          <p:cNvPr id="27" name="Text 25"/>
+          <p:cNvSpPr txBox="1"/>
+          <p:nvPr/>
+        </p:nvSpPr>
+        <p:spPr>
+          <a:xfrm>
+            <a:off x="6995160" y="3886200"/>
+            <a:ext cx="1691640" cy="731520"/>
+          </a:xfrm>
+          <a:prstGeom prst="rect">
+            <a:avLst/>
+          </a:prstGeom>
+          <a:noFill/>
+          <a:ln/>
+        </p:spPr>
+        <p:txBody>
+          <a:bodyPr wrap="square" lIns="0" tIns="0" rIns="0" bIns="0" rtlCol="0" anchor="ctr"/>
+          <a:lstStyle/>
+          <a:p>
+            <a:pPr indent="0" marL="0">
+              <a:buNone/>
+            </a:pPr>
+            <a:r>
+              <a:rPr lang="en-US" sz="1150" dirty="0">
+                <a:solidFill>
+                  <a:schemeClr val="tx1"/>
+                </a:solidFill>
+              </a:rPr>
+              <a:t>Once paid, we book the kickoff and start</a:t>
+            </a:r>
+            <a:endParaRPr lang="en-US" sz="1150" dirty="0"/>
           </a:p>
         </p:txBody>
       </p:sp>

</xml_diff>